<commit_message>
folien: rezept-folie mit durchlaufendem beispiel statt formelkarten
</commit_message>
<xml_diff>
--- a/folien/dist/02-adressierung-subnetting-parallelkurs.pptx
+++ b/folien/dist/02-adressierung-subnetting-parallelkurs.pptx
@@ -15622,36 +15622,40 @@
           </a:p>
         </p:txBody>
       </p:sp>
-      <p:sp>
-        <p:nvSpPr>
-          <p:cNvPr id="5" name="Shape 3"/>
-          <p:cNvSpPr/>
-          <p:nvPr/>
-        </p:nvSpPr>
-        <p:spPr>
-          <a:xfrm>
-            <a:off x="566928" y="1737360"/>
-            <a:ext cx="1879092" cy="2103120"/>
-          </a:xfrm>
-          <a:prstGeom prst="rect">
-            <a:avLst/>
-          </a:prstGeom>
-          <a:solidFill>
-            <a:srgbClr val="F5F6FC"/>
-          </a:solidFill>
-          <a:ln/>
-        </p:spPr>
-      </p:sp>
-      <p:sp>
-        <p:nvSpPr>
-          <p:cNvPr id="6" name="Shape 4"/>
-          <p:cNvSpPr/>
-          <p:nvPr/>
-        </p:nvSpPr>
-        <p:spPr>
-          <a:xfrm>
-            <a:off x="566928" y="1737360"/>
-            <a:ext cx="41148" cy="2103120"/>
+      <p:pic>
+        <p:nvPicPr>
+          <p:cNvPr id="5" name="Image 0" descr="/Users/jacobmenge/Desktop/kurs-unterlagen/folien/assets/diagramme/rezept-weg.png">    </p:cNvPr>
+          <p:cNvPicPr>
+            <a:picLocks noChangeAspect="1"/>
+          </p:cNvPicPr>
+          <p:nvPr/>
+        </p:nvPicPr>
+        <p:blipFill>
+          <a:blip r:embed="rId1"/>
+          <a:stretch>
+            <a:fillRect/>
+          </a:stretch>
+        </p:blipFill>
+        <p:spPr>
+          <a:xfrm>
+            <a:off x="566928" y="1572768"/>
+            <a:ext cx="8010144" cy="2286000"/>
+          </a:xfrm>
+          <a:prstGeom prst="rect">
+            <a:avLst/>
+          </a:prstGeom>
+        </p:spPr>
+      </p:pic>
+      <p:sp>
+        <p:nvSpPr>
+          <p:cNvPr id="6" name="Shape 3"/>
+          <p:cNvSpPr/>
+          <p:nvPr/>
+        </p:nvSpPr>
+        <p:spPr>
+          <a:xfrm>
+            <a:off x="566928" y="4160520"/>
+            <a:ext cx="32004" cy="256032"/>
           </a:xfrm>
           <a:prstGeom prst="rect">
             <a:avLst/>
@@ -15664,471 +15668,7 @@
       </p:sp>
       <p:sp>
         <p:nvSpPr>
-          <p:cNvPr id="7" name="Text 5"/>
-          <p:cNvSpPr/>
-          <p:nvPr/>
-        </p:nvSpPr>
-        <p:spPr>
-          <a:xfrm>
-            <a:off x="804672" y="1883664"/>
-            <a:ext cx="1476756" cy="274320"/>
-          </a:xfrm>
-          <a:prstGeom prst="rect">
-            <a:avLst/>
-          </a:prstGeom>
-          <a:noFill/>
-          <a:ln/>
-        </p:spPr>
-        <p:txBody>
-          <a:bodyPr wrap="square" lIns="0" tIns="0" rIns="0" bIns="0" rtlCol="0" anchor="t"/>
-          <a:lstStyle/>
-          <a:p>
-            <a:pPr indent="0" marL="0">
-              <a:buNone/>
-            </a:pPr>
-            <a:r>
-              <a:rPr lang="en-US" sz="1300" b="1" dirty="0">
-                <a:solidFill>
-                  <a:srgbClr val="272E52"/>
-                </a:solidFill>
-                <a:latin typeface="Arial" pitchFamily="34" charset="0"/>
-                <a:ea typeface="Arial" pitchFamily="34" charset="-122"/>
-                <a:cs typeface="Arial" pitchFamily="34" charset="-120"/>
-              </a:rPr>
-              <a:t>1 · Hostbits</a:t>
-            </a:r>
-            <a:endParaRPr lang="en-US" sz="1300" dirty="0"/>
-          </a:p>
-        </p:txBody>
-      </p:sp>
-      <p:sp>
-        <p:nvSpPr>
-          <p:cNvPr id="8" name="Text 6"/>
-          <p:cNvSpPr/>
-          <p:nvPr/>
-        </p:nvSpPr>
-        <p:spPr>
-          <a:xfrm>
-            <a:off x="804672" y="2203704"/>
-            <a:ext cx="1476756" cy="1517904"/>
-          </a:xfrm>
-          <a:prstGeom prst="rect">
-            <a:avLst/>
-          </a:prstGeom>
-          <a:noFill/>
-          <a:ln/>
-        </p:spPr>
-        <p:txBody>
-          <a:bodyPr wrap="square" lIns="0" tIns="0" rIns="0" bIns="0" rtlCol="0" anchor="t"/>
-          <a:lstStyle/>
-          <a:p>
-            <a:pPr indent="0" marL="0">
-              <a:lnSpc>
-                <a:spcPct val="92000"/>
-              </a:lnSpc>
-              <a:buNone/>
-            </a:pPr>
-            <a:r>
-              <a:rPr lang="en-US" sz="1100" dirty="0">
-                <a:solidFill>
-                  <a:srgbClr val="434A63"/>
-                </a:solidFill>
-                <a:latin typeface="Arial" pitchFamily="34" charset="0"/>
-                <a:ea typeface="Arial" pitchFamily="34" charset="-122"/>
-                <a:cs typeface="Arial" pitchFamily="34" charset="-120"/>
-              </a:rPr>
-              <a:t>32 minus Präfix. Bei /26: 32 − 26 = 6 Hostbits.</a:t>
-            </a:r>
-            <a:endParaRPr lang="en-US" sz="1100" dirty="0"/>
-          </a:p>
-        </p:txBody>
-      </p:sp>
-      <p:sp>
-        <p:nvSpPr>
-          <p:cNvPr id="9" name="Shape 7"/>
-          <p:cNvSpPr/>
-          <p:nvPr/>
-        </p:nvSpPr>
-        <p:spPr>
-          <a:xfrm>
-            <a:off x="2610612" y="1737360"/>
-            <a:ext cx="1879092" cy="2103120"/>
-          </a:xfrm>
-          <a:prstGeom prst="rect">
-            <a:avLst/>
-          </a:prstGeom>
-          <a:solidFill>
-            <a:srgbClr val="F5F6FC"/>
-          </a:solidFill>
-          <a:ln/>
-        </p:spPr>
-      </p:sp>
-      <p:sp>
-        <p:nvSpPr>
-          <p:cNvPr id="10" name="Shape 8"/>
-          <p:cNvSpPr/>
-          <p:nvPr/>
-        </p:nvSpPr>
-        <p:spPr>
-          <a:xfrm>
-            <a:off x="2610612" y="1737360"/>
-            <a:ext cx="41148" cy="2103120"/>
-          </a:xfrm>
-          <a:prstGeom prst="rect">
-            <a:avLst/>
-          </a:prstGeom>
-          <a:solidFill>
-            <a:srgbClr val="0F7C86"/>
-          </a:solidFill>
-          <a:ln/>
-        </p:spPr>
-      </p:sp>
-      <p:sp>
-        <p:nvSpPr>
-          <p:cNvPr id="11" name="Text 9"/>
-          <p:cNvSpPr/>
-          <p:nvPr/>
-        </p:nvSpPr>
-        <p:spPr>
-          <a:xfrm>
-            <a:off x="2848356" y="1883664"/>
-            <a:ext cx="1476756" cy="274320"/>
-          </a:xfrm>
-          <a:prstGeom prst="rect">
-            <a:avLst/>
-          </a:prstGeom>
-          <a:noFill/>
-          <a:ln/>
-        </p:spPr>
-        <p:txBody>
-          <a:bodyPr wrap="square" lIns="0" tIns="0" rIns="0" bIns="0" rtlCol="0" anchor="t"/>
-          <a:lstStyle/>
-          <a:p>
-            <a:pPr indent="0" marL="0">
-              <a:buNone/>
-            </a:pPr>
-            <a:r>
-              <a:rPr lang="en-US" sz="1300" b="1" dirty="0">
-                <a:solidFill>
-                  <a:srgbClr val="272E52"/>
-                </a:solidFill>
-                <a:latin typeface="Arial" pitchFamily="34" charset="0"/>
-                <a:ea typeface="Arial" pitchFamily="34" charset="-122"/>
-                <a:cs typeface="Arial" pitchFamily="34" charset="-120"/>
-              </a:rPr>
-              <a:t>2 · Blockgröße</a:t>
-            </a:r>
-            <a:endParaRPr lang="en-US" sz="1300" dirty="0"/>
-          </a:p>
-        </p:txBody>
-      </p:sp>
-      <p:sp>
-        <p:nvSpPr>
-          <p:cNvPr id="12" name="Text 10"/>
-          <p:cNvSpPr/>
-          <p:nvPr/>
-        </p:nvSpPr>
-        <p:spPr>
-          <a:xfrm>
-            <a:off x="2848356" y="2203704"/>
-            <a:ext cx="1476756" cy="1517904"/>
-          </a:xfrm>
-          <a:prstGeom prst="rect">
-            <a:avLst/>
-          </a:prstGeom>
-          <a:noFill/>
-          <a:ln/>
-        </p:spPr>
-        <p:txBody>
-          <a:bodyPr wrap="square" lIns="0" tIns="0" rIns="0" bIns="0" rtlCol="0" anchor="t"/>
-          <a:lstStyle/>
-          <a:p>
-            <a:pPr indent="0" marL="0">
-              <a:lnSpc>
-                <a:spcPct val="92000"/>
-              </a:lnSpc>
-              <a:buNone/>
-            </a:pPr>
-            <a:r>
-              <a:rPr lang="en-US" sz="1100" dirty="0">
-                <a:solidFill>
-                  <a:srgbClr val="434A63"/>
-                </a:solidFill>
-                <a:latin typeface="Arial" pitchFamily="34" charset="0"/>
-                <a:ea typeface="Arial" pitchFamily="34" charset="-122"/>
-                <a:cs typeface="Arial" pitchFamily="34" charset="-120"/>
-              </a:rPr>
-              <a:t>2 hoch Hostbits. 2⁶ = 64 – die Netze starten bei 0, 64, 128, 192.</a:t>
-            </a:r>
-            <a:endParaRPr lang="en-US" sz="1100" dirty="0"/>
-          </a:p>
-        </p:txBody>
-      </p:sp>
-      <p:sp>
-        <p:nvSpPr>
-          <p:cNvPr id="13" name="Shape 11"/>
-          <p:cNvSpPr/>
-          <p:nvPr/>
-        </p:nvSpPr>
-        <p:spPr>
-          <a:xfrm>
-            <a:off x="4654296" y="1737360"/>
-            <a:ext cx="1879092" cy="2103120"/>
-          </a:xfrm>
-          <a:prstGeom prst="rect">
-            <a:avLst/>
-          </a:prstGeom>
-          <a:solidFill>
-            <a:srgbClr val="F5F6FC"/>
-          </a:solidFill>
-          <a:ln/>
-        </p:spPr>
-      </p:sp>
-      <p:sp>
-        <p:nvSpPr>
-          <p:cNvPr id="14" name="Shape 12"/>
-          <p:cNvSpPr/>
-          <p:nvPr/>
-        </p:nvSpPr>
-        <p:spPr>
-          <a:xfrm>
-            <a:off x="4654296" y="1737360"/>
-            <a:ext cx="41148" cy="2103120"/>
-          </a:xfrm>
-          <a:prstGeom prst="rect">
-            <a:avLst/>
-          </a:prstGeom>
-          <a:solidFill>
-            <a:srgbClr val="0F7C86"/>
-          </a:solidFill>
-          <a:ln/>
-        </p:spPr>
-      </p:sp>
-      <p:sp>
-        <p:nvSpPr>
-          <p:cNvPr id="15" name="Text 13"/>
-          <p:cNvSpPr/>
-          <p:nvPr/>
-        </p:nvSpPr>
-        <p:spPr>
-          <a:xfrm>
-            <a:off x="4892040" y="1883664"/>
-            <a:ext cx="1476756" cy="456692"/>
-          </a:xfrm>
-          <a:prstGeom prst="rect">
-            <a:avLst/>
-          </a:prstGeom>
-          <a:noFill/>
-          <a:ln/>
-        </p:spPr>
-        <p:txBody>
-          <a:bodyPr wrap="square" lIns="0" tIns="0" rIns="0" bIns="0" rtlCol="0" anchor="t"/>
-          <a:lstStyle/>
-          <a:p>
-            <a:pPr indent="0" marL="0">
-              <a:buNone/>
-            </a:pPr>
-            <a:r>
-              <a:rPr lang="en-US" sz="1300" b="1" dirty="0">
-                <a:solidFill>
-                  <a:srgbClr val="272E52"/>
-                </a:solidFill>
-                <a:latin typeface="Arial" pitchFamily="34" charset="0"/>
-                <a:ea typeface="Arial" pitchFamily="34" charset="-122"/>
-                <a:cs typeface="Arial" pitchFamily="34" charset="-120"/>
-              </a:rPr>
-              <a:t>3 · Block finden</a:t>
-            </a:r>
-            <a:endParaRPr lang="en-US" sz="1300" dirty="0"/>
-          </a:p>
-        </p:txBody>
-      </p:sp>
-      <p:sp>
-        <p:nvSpPr>
-          <p:cNvPr id="16" name="Text 14"/>
-          <p:cNvSpPr/>
-          <p:nvPr/>
-        </p:nvSpPr>
-        <p:spPr>
-          <a:xfrm>
-            <a:off x="4892040" y="2386076"/>
-            <a:ext cx="1476756" cy="1335532"/>
-          </a:xfrm>
-          <a:prstGeom prst="rect">
-            <a:avLst/>
-          </a:prstGeom>
-          <a:noFill/>
-          <a:ln/>
-        </p:spPr>
-        <p:txBody>
-          <a:bodyPr wrap="square" lIns="0" tIns="0" rIns="0" bIns="0" rtlCol="0" anchor="t"/>
-          <a:lstStyle/>
-          <a:p>
-            <a:pPr indent="0" marL="0">
-              <a:lnSpc>
-                <a:spcPct val="92000"/>
-              </a:lnSpc>
-              <a:buNone/>
-            </a:pPr>
-            <a:r>
-              <a:rPr lang="en-US" sz="1100" dirty="0">
-                <a:solidFill>
-                  <a:srgbClr val="434A63"/>
-                </a:solidFill>
-                <a:latin typeface="Arial" pitchFamily="34" charset="0"/>
-                <a:ea typeface="Arial" pitchFamily="34" charset="-122"/>
-                <a:cs typeface="Arial" pitchFamily="34" charset="-120"/>
-              </a:rPr>
-              <a:t>In welchem Block liegt die Adresse? Der Blockanfang ist die Netzadresse.</a:t>
-            </a:r>
-            <a:endParaRPr lang="en-US" sz="1100" dirty="0"/>
-          </a:p>
-        </p:txBody>
-      </p:sp>
-      <p:sp>
-        <p:nvSpPr>
-          <p:cNvPr id="17" name="Shape 15"/>
-          <p:cNvSpPr/>
-          <p:nvPr/>
-        </p:nvSpPr>
-        <p:spPr>
-          <a:xfrm>
-            <a:off x="6697980" y="1737360"/>
-            <a:ext cx="1879092" cy="2103120"/>
-          </a:xfrm>
-          <a:prstGeom prst="rect">
-            <a:avLst/>
-          </a:prstGeom>
-          <a:solidFill>
-            <a:srgbClr val="F5F6FC"/>
-          </a:solidFill>
-          <a:ln/>
-        </p:spPr>
-      </p:sp>
-      <p:sp>
-        <p:nvSpPr>
-          <p:cNvPr id="18" name="Shape 16"/>
-          <p:cNvSpPr/>
-          <p:nvPr/>
-        </p:nvSpPr>
-        <p:spPr>
-          <a:xfrm>
-            <a:off x="6697980" y="1737360"/>
-            <a:ext cx="41148" cy="2103120"/>
-          </a:xfrm>
-          <a:prstGeom prst="rect">
-            <a:avLst/>
-          </a:prstGeom>
-          <a:solidFill>
-            <a:srgbClr val="0F7C86"/>
-          </a:solidFill>
-          <a:ln/>
-        </p:spPr>
-      </p:sp>
-      <p:sp>
-        <p:nvSpPr>
-          <p:cNvPr id="19" name="Text 17"/>
-          <p:cNvSpPr/>
-          <p:nvPr/>
-        </p:nvSpPr>
-        <p:spPr>
-          <a:xfrm>
-            <a:off x="6935724" y="1883664"/>
-            <a:ext cx="1476756" cy="274320"/>
-          </a:xfrm>
-          <a:prstGeom prst="rect">
-            <a:avLst/>
-          </a:prstGeom>
-          <a:noFill/>
-          <a:ln/>
-        </p:spPr>
-        <p:txBody>
-          <a:bodyPr wrap="square" lIns="0" tIns="0" rIns="0" bIns="0" rtlCol="0" anchor="t"/>
-          <a:lstStyle/>
-          <a:p>
-            <a:pPr indent="0" marL="0">
-              <a:buNone/>
-            </a:pPr>
-            <a:r>
-              <a:rPr lang="en-US" sz="1300" b="1" dirty="0">
-                <a:solidFill>
-                  <a:srgbClr val="272E52"/>
-                </a:solidFill>
-                <a:latin typeface="Arial" pitchFamily="34" charset="0"/>
-                <a:ea typeface="Arial" pitchFamily="34" charset="-122"/>
-                <a:cs typeface="Arial" pitchFamily="34" charset="-120"/>
-              </a:rPr>
-              <a:t>4 · Minus zwei</a:t>
-            </a:r>
-            <a:endParaRPr lang="en-US" sz="1300" dirty="0"/>
-          </a:p>
-        </p:txBody>
-      </p:sp>
-      <p:sp>
-        <p:nvSpPr>
-          <p:cNvPr id="20" name="Text 18"/>
-          <p:cNvSpPr/>
-          <p:nvPr/>
-        </p:nvSpPr>
-        <p:spPr>
-          <a:xfrm>
-            <a:off x="6935724" y="2203704"/>
-            <a:ext cx="1476756" cy="1517904"/>
-          </a:xfrm>
-          <a:prstGeom prst="rect">
-            <a:avLst/>
-          </a:prstGeom>
-          <a:noFill/>
-          <a:ln/>
-        </p:spPr>
-        <p:txBody>
-          <a:bodyPr wrap="square" lIns="0" tIns="0" rIns="0" bIns="0" rtlCol="0" anchor="t"/>
-          <a:lstStyle/>
-          <a:p>
-            <a:pPr indent="0" marL="0">
-              <a:lnSpc>
-                <a:spcPct val="92000"/>
-              </a:lnSpc>
-              <a:buNone/>
-            </a:pPr>
-            <a:r>
-              <a:rPr lang="en-US" sz="1100" dirty="0">
-                <a:solidFill>
-                  <a:srgbClr val="434A63"/>
-                </a:solidFill>
-                <a:latin typeface="Arial" pitchFamily="34" charset="0"/>
-                <a:ea typeface="Arial" pitchFamily="34" charset="-122"/>
-                <a:cs typeface="Arial" pitchFamily="34" charset="-120"/>
-              </a:rPr>
-              <a:t>Erste Adresse = Netz, letzte = Broadcast. Nutzbar ist, was dazwischen liegt.</a:t>
-            </a:r>
-            <a:endParaRPr lang="en-US" sz="1100" dirty="0"/>
-          </a:p>
-        </p:txBody>
-      </p:sp>
-      <p:sp>
-        <p:nvSpPr>
-          <p:cNvPr id="21" name="Shape 19"/>
-          <p:cNvSpPr/>
-          <p:nvPr/>
-        </p:nvSpPr>
-        <p:spPr>
-          <a:xfrm>
-            <a:off x="566928" y="4160520"/>
-            <a:ext cx="32004" cy="256032"/>
-          </a:xfrm>
-          <a:prstGeom prst="rect">
-            <a:avLst/>
-          </a:prstGeom>
-          <a:solidFill>
-            <a:srgbClr val="0F7C86"/>
-          </a:solidFill>
-          <a:ln/>
-        </p:spPr>
-      </p:sp>
-      <p:sp>
-        <p:nvSpPr>
-          <p:cNvPr id="22" name="Text 20"/>
+          <p:cNvPr id="7" name="Text 4"/>
           <p:cNvSpPr/>
           <p:nvPr/>
         </p:nvSpPr>
@@ -16167,7 +15707,7 @@
       </p:sp>
       <p:sp>
         <p:nvSpPr>
-          <p:cNvPr id="23" name="Shape 21"/>
+          <p:cNvPr id="8" name="Shape 5"/>
           <p:cNvSpPr/>
           <p:nvPr/>
         </p:nvSpPr>
@@ -16190,7 +15730,7 @@
       </p:sp>
       <p:sp>
         <p:nvSpPr>
-          <p:cNvPr id="24" name="Text 22"/>
+          <p:cNvPr id="9" name="Text 6"/>
           <p:cNvSpPr/>
           <p:nvPr/>
         </p:nvSpPr>
@@ -16229,7 +15769,7 @@
       </p:sp>
       <p:sp>
         <p:nvSpPr>
-          <p:cNvPr id="25" name="Text 23"/>
+          <p:cNvPr id="10" name="Text 7"/>
           <p:cNvSpPr/>
           <p:nvPr/>
         </p:nvSpPr>

</xml_diff>

<commit_message>
folien: aufgaben als gegeben-gesucht-bilder, nat-beschriftung von den pfeilen geloest
</commit_message>
<xml_diff>
--- a/folien/dist/02-adressierung-subnetting-parallelkurs.pptx
+++ b/folien/dist/02-adressierung-subnetting-parallelkurs.pptx
@@ -3453,130 +3453,9 @@
           </a:p>
         </p:txBody>
       </p:sp>
-      <p:sp>
-        <p:nvSpPr>
-          <p:cNvPr id="5" name="Shape 3"/>
-          <p:cNvSpPr/>
-          <p:nvPr/>
-        </p:nvSpPr>
-        <p:spPr>
-          <a:xfrm>
-            <a:off x="566928" y="1627632"/>
-            <a:ext cx="8010144" cy="1005840"/>
-          </a:xfrm>
-          <a:prstGeom prst="rect">
-            <a:avLst/>
-          </a:prstGeom>
-          <a:solidFill>
-            <a:srgbClr val="F5F6FC"/>
-          </a:solidFill>
-          <a:ln/>
-        </p:spPr>
-      </p:sp>
-      <p:sp>
-        <p:nvSpPr>
-          <p:cNvPr id="6" name="Shape 4"/>
-          <p:cNvSpPr/>
-          <p:nvPr/>
-        </p:nvSpPr>
-        <p:spPr>
-          <a:xfrm>
-            <a:off x="566928" y="1627632"/>
-            <a:ext cx="41148" cy="1005840"/>
-          </a:xfrm>
-          <a:prstGeom prst="rect">
-            <a:avLst/>
-          </a:prstGeom>
-          <a:solidFill>
-            <a:srgbClr val="0F7C86"/>
-          </a:solidFill>
-          <a:ln/>
-        </p:spPr>
-      </p:sp>
-      <p:sp>
-        <p:nvSpPr>
-          <p:cNvPr id="7" name="Text 5"/>
-          <p:cNvSpPr/>
-          <p:nvPr/>
-        </p:nvSpPr>
-        <p:spPr>
-          <a:xfrm>
-            <a:off x="804672" y="1773936"/>
-            <a:ext cx="7607808" cy="292608"/>
-          </a:xfrm>
-          <a:prstGeom prst="rect">
-            <a:avLst/>
-          </a:prstGeom>
-          <a:noFill/>
-          <a:ln/>
-        </p:spPr>
-        <p:txBody>
-          <a:bodyPr wrap="square" lIns="0" tIns="0" rIns="0" bIns="0" rtlCol="0" anchor="t"/>
-          <a:lstStyle/>
-          <a:p>
-            <a:pPr indent="0" marL="0">
-              <a:buNone/>
-            </a:pPr>
-            <a:r>
-              <a:rPr lang="en-US" sz="1400" b="1" dirty="0">
-                <a:solidFill>
-                  <a:srgbClr val="272E52"/>
-                </a:solidFill>
-                <a:latin typeface="Arial" pitchFamily="34" charset="0"/>
-                <a:ea typeface="Arial" pitchFamily="34" charset="-122"/>
-                <a:cs typeface="Arial" pitchFamily="34" charset="-120"/>
-              </a:rPr>
-              <a:t>Die Adresse 192.168.10.77 liegt in einem /26-Netz.</a:t>
-            </a:r>
-            <a:endParaRPr lang="en-US" sz="1400" dirty="0"/>
-          </a:p>
-        </p:txBody>
-      </p:sp>
-      <p:sp>
-        <p:nvSpPr>
-          <p:cNvPr id="8" name="Text 6"/>
-          <p:cNvSpPr/>
-          <p:nvPr/>
-        </p:nvSpPr>
-        <p:spPr>
-          <a:xfrm>
-            <a:off x="804672" y="2112264"/>
-            <a:ext cx="7607808" cy="402336"/>
-          </a:xfrm>
-          <a:prstGeom prst="rect">
-            <a:avLst/>
-          </a:prstGeom>
-          <a:noFill/>
-          <a:ln/>
-        </p:spPr>
-        <p:txBody>
-          <a:bodyPr wrap="square" lIns="0" tIns="0" rIns="0" bIns="0" rtlCol="0" anchor="t"/>
-          <a:lstStyle/>
-          <a:p>
-            <a:pPr indent="0" marL="0">
-              <a:lnSpc>
-                <a:spcPct val="92000"/>
-              </a:lnSpc>
-              <a:buNone/>
-            </a:pPr>
-            <a:r>
-              <a:rPr lang="en-US" sz="1300" dirty="0">
-                <a:solidFill>
-                  <a:srgbClr val="434A63"/>
-                </a:solidFill>
-                <a:latin typeface="Arial" pitchFamily="34" charset="0"/>
-                <a:ea typeface="Arial" pitchFamily="34" charset="-122"/>
-                <a:cs typeface="Arial" pitchFamily="34" charset="-120"/>
-              </a:rPr>
-              <a:t>Netzadresse, erste und letzte nutzbare Adresse, Broadcast?</a:t>
-            </a:r>
-            <a:endParaRPr lang="en-US" sz="1300" dirty="0"/>
-          </a:p>
-        </p:txBody>
-      </p:sp>
       <p:pic>
         <p:nvPicPr>
-          <p:cNvPr id="9" name="Image 0" descr="/Users/jacobmenge/Desktop/kurs-unterlagen/folien/assets/diagramme/block-strahl.png">    </p:cNvPr>
+          <p:cNvPr id="5" name="Image 0" descr="/Users/jacobmenge/Desktop/kurs-unterlagen/folien/assets/diagramme/aufgabe-a-geloest.png">    </p:cNvPr>
           <p:cNvPicPr>
             <a:picLocks noChangeAspect="1"/>
           </p:cNvPicPr>
@@ -3590,7 +3469,31 @@
         </p:blipFill>
         <p:spPr>
           <a:xfrm>
-            <a:off x="566928" y="2788920"/>
+            <a:off x="566928" y="1572768"/>
+            <a:ext cx="8010144" cy="1536192"/>
+          </a:xfrm>
+          <a:prstGeom prst="rect">
+            <a:avLst/>
+          </a:prstGeom>
+        </p:spPr>
+      </p:pic>
+      <p:pic>
+        <p:nvPicPr>
+          <p:cNvPr id="6" name="Image 1" descr="/Users/jacobmenge/Desktop/kurs-unterlagen/folien/assets/diagramme/block-strahl.png">    </p:cNvPr>
+          <p:cNvPicPr>
+            <a:picLocks noChangeAspect="1"/>
+          </p:cNvPicPr>
+          <p:nvPr/>
+        </p:nvPicPr>
+        <p:blipFill>
+          <a:blip r:embed="rId2"/>
+          <a:stretch>
+            <a:fillRect/>
+          </a:stretch>
+        </p:blipFill>
+        <p:spPr>
+          <a:xfrm>
+            <a:off x="566928" y="3200400"/>
             <a:ext cx="8010144" cy="1115568"/>
           </a:xfrm>
           <a:prstGeom prst="rect">
@@ -3600,66 +3503,7 @@
       </p:pic>
       <p:sp>
         <p:nvSpPr>
-          <p:cNvPr id="10" name="Shape 7"/>
-          <p:cNvSpPr/>
-          <p:nvPr/>
-        </p:nvSpPr>
-        <p:spPr>
-          <a:xfrm>
-            <a:off x="566928" y="4160520"/>
-            <a:ext cx="32004" cy="256032"/>
-          </a:xfrm>
-          <a:prstGeom prst="rect">
-            <a:avLst/>
-          </a:prstGeom>
-          <a:solidFill>
-            <a:srgbClr val="0F7C86"/>
-          </a:solidFill>
-          <a:ln/>
-        </p:spPr>
-      </p:sp>
-      <p:sp>
-        <p:nvSpPr>
-          <p:cNvPr id="11" name="Text 8"/>
-          <p:cNvSpPr/>
-          <p:nvPr/>
-        </p:nvSpPr>
-        <p:spPr>
-          <a:xfrm>
-            <a:off x="749808" y="4114800"/>
-            <a:ext cx="7827264" cy="402336"/>
-          </a:xfrm>
-          <a:prstGeom prst="rect">
-            <a:avLst/>
-          </a:prstGeom>
-          <a:noFill/>
-          <a:ln/>
-        </p:spPr>
-        <p:txBody>
-          <a:bodyPr wrap="square" lIns="0" tIns="0" rIns="0" bIns="0" rtlCol="0" anchor="ctr"/>
-          <a:lstStyle/>
-          <a:p>
-            <a:pPr indent="0" marL="0">
-              <a:buNone/>
-            </a:pPr>
-            <a:r>
-              <a:rPr lang="en-US" sz="1200" b="1" dirty="0">
-                <a:solidFill>
-                  <a:srgbClr val="434A63"/>
-                </a:solidFill>
-                <a:latin typeface="Arial" pitchFamily="34" charset="0"/>
-                <a:ea typeface="Arial" pitchFamily="34" charset="-122"/>
-                <a:cs typeface="Arial" pitchFamily="34" charset="-120"/>
-              </a:rPr>
-              <a:t>Nutzbar .65 bis .126 – der Blockanfang benennt das Netz, die letzte Adresse ruft alle.</a:t>
-            </a:r>
-            <a:endParaRPr lang="en-US" sz="1200" dirty="0"/>
-          </a:p>
-        </p:txBody>
-      </p:sp>
-      <p:sp>
-        <p:nvSpPr>
-          <p:cNvPr id="12" name="Shape 9"/>
+          <p:cNvPr id="7" name="Shape 3"/>
           <p:cNvSpPr/>
           <p:nvPr/>
         </p:nvSpPr>
@@ -3682,7 +3526,7 @@
       </p:sp>
       <p:sp>
         <p:nvSpPr>
-          <p:cNvPr id="13" name="Text 10"/>
+          <p:cNvPr id="8" name="Text 4"/>
           <p:cNvSpPr/>
           <p:nvPr/>
         </p:nvSpPr>
@@ -3721,7 +3565,7 @@
       </p:sp>
       <p:sp>
         <p:nvSpPr>
-          <p:cNvPr id="14" name="Text 11"/>
+          <p:cNvPr id="9" name="Text 5"/>
           <p:cNvSpPr/>
           <p:nvPr/>
         </p:nvSpPr>
@@ -3888,36 +3732,40 @@
           </a:p>
         </p:txBody>
       </p:sp>
-      <p:sp>
-        <p:nvSpPr>
-          <p:cNvPr id="5" name="Shape 3"/>
-          <p:cNvSpPr/>
-          <p:nvPr/>
-        </p:nvSpPr>
-        <p:spPr>
-          <a:xfrm>
-            <a:off x="566928" y="1627632"/>
-            <a:ext cx="8010144" cy="1005840"/>
-          </a:xfrm>
-          <a:prstGeom prst="rect">
-            <a:avLst/>
-          </a:prstGeom>
-          <a:solidFill>
-            <a:srgbClr val="F5F6FC"/>
-          </a:solidFill>
-          <a:ln/>
-        </p:spPr>
-      </p:sp>
-      <p:sp>
-        <p:nvSpPr>
-          <p:cNvPr id="6" name="Shape 4"/>
-          <p:cNvSpPr/>
-          <p:nvPr/>
-        </p:nvSpPr>
-        <p:spPr>
-          <a:xfrm>
-            <a:off x="566928" y="1627632"/>
-            <a:ext cx="41148" cy="1005840"/>
+      <p:pic>
+        <p:nvPicPr>
+          <p:cNvPr id="5" name="Image 0" descr="/Users/jacobmenge/Desktop/kurs-unterlagen/folien/assets/diagramme/aufgabe-b-frage.png">    </p:cNvPr>
+          <p:cNvPicPr>
+            <a:picLocks noChangeAspect="1"/>
+          </p:cNvPicPr>
+          <p:nvPr/>
+        </p:nvPicPr>
+        <p:blipFill>
+          <a:blip r:embed="rId1"/>
+          <a:stretch>
+            <a:fillRect/>
+          </a:stretch>
+        </p:blipFill>
+        <p:spPr>
+          <a:xfrm>
+            <a:off x="566928" y="1874520"/>
+            <a:ext cx="8010144" cy="1536192"/>
+          </a:xfrm>
+          <a:prstGeom prst="rect">
+            <a:avLst/>
+          </a:prstGeom>
+        </p:spPr>
+      </p:pic>
+      <p:sp>
+        <p:nvSpPr>
+          <p:cNvPr id="6" name="Shape 3"/>
+          <p:cNvSpPr/>
+          <p:nvPr/>
+        </p:nvSpPr>
+        <p:spPr>
+          <a:xfrm>
+            <a:off x="566928" y="4160520"/>
+            <a:ext cx="32004" cy="256032"/>
           </a:xfrm>
           <a:prstGeom prst="rect">
             <a:avLst/>
@@ -3930,108 +3778,7 @@
       </p:sp>
       <p:sp>
         <p:nvSpPr>
-          <p:cNvPr id="7" name="Text 5"/>
-          <p:cNvSpPr/>
-          <p:nvPr/>
-        </p:nvSpPr>
-        <p:spPr>
-          <a:xfrm>
-            <a:off x="804672" y="1773936"/>
-            <a:ext cx="7607808" cy="292608"/>
-          </a:xfrm>
-          <a:prstGeom prst="rect">
-            <a:avLst/>
-          </a:prstGeom>
-          <a:noFill/>
-          <a:ln/>
-        </p:spPr>
-        <p:txBody>
-          <a:bodyPr wrap="square" lIns="0" tIns="0" rIns="0" bIns="0" rtlCol="0" anchor="t"/>
-          <a:lstStyle/>
-          <a:p>
-            <a:pPr indent="0" marL="0">
-              <a:buNone/>
-            </a:pPr>
-            <a:r>
-              <a:rPr lang="en-US" sz="1400" b="1" dirty="0">
-                <a:solidFill>
-                  <a:srgbClr val="272E52"/>
-                </a:solidFill>
-                <a:latin typeface="Arial" pitchFamily="34" charset="0"/>
-                <a:ea typeface="Arial" pitchFamily="34" charset="-122"/>
-                <a:cs typeface="Arial" pitchFamily="34" charset="-120"/>
-              </a:rPr>
-              <a:t>Eine Abteilung braucht Platz für 40 Geräte.</a:t>
-            </a:r>
-            <a:endParaRPr lang="en-US" sz="1400" dirty="0"/>
-          </a:p>
-        </p:txBody>
-      </p:sp>
-      <p:sp>
-        <p:nvSpPr>
-          <p:cNvPr id="8" name="Text 6"/>
-          <p:cNvSpPr/>
-          <p:nvPr/>
-        </p:nvSpPr>
-        <p:spPr>
-          <a:xfrm>
-            <a:off x="804672" y="2112264"/>
-            <a:ext cx="7607808" cy="402336"/>
-          </a:xfrm>
-          <a:prstGeom prst="rect">
-            <a:avLst/>
-          </a:prstGeom>
-          <a:noFill/>
-          <a:ln/>
-        </p:spPr>
-        <p:txBody>
-          <a:bodyPr wrap="square" lIns="0" tIns="0" rIns="0" bIns="0" rtlCol="0" anchor="t"/>
-          <a:lstStyle/>
-          <a:p>
-            <a:pPr indent="0" marL="0">
-              <a:lnSpc>
-                <a:spcPct val="92000"/>
-              </a:lnSpc>
-              <a:buNone/>
-            </a:pPr>
-            <a:r>
-              <a:rPr lang="en-US" sz="1300" dirty="0">
-                <a:solidFill>
-                  <a:srgbClr val="434A63"/>
-                </a:solidFill>
-                <a:latin typeface="Arial" pitchFamily="34" charset="0"/>
-                <a:ea typeface="Arial" pitchFamily="34" charset="-122"/>
-                <a:cs typeface="Arial" pitchFamily="34" charset="-120"/>
-              </a:rPr>
-              <a:t>Welches Präfix nehmt ihr – und warum nicht eins kleiner?</a:t>
-            </a:r>
-            <a:endParaRPr lang="en-US" sz="1300" dirty="0"/>
-          </a:p>
-        </p:txBody>
-      </p:sp>
-      <p:sp>
-        <p:nvSpPr>
-          <p:cNvPr id="9" name="Shape 7"/>
-          <p:cNvSpPr/>
-          <p:nvPr/>
-        </p:nvSpPr>
-        <p:spPr>
-          <a:xfrm>
-            <a:off x="566928" y="4160520"/>
-            <a:ext cx="32004" cy="256032"/>
-          </a:xfrm>
-          <a:prstGeom prst="rect">
-            <a:avLst/>
-          </a:prstGeom>
-          <a:solidFill>
-            <a:srgbClr val="0F7C86"/>
-          </a:solidFill>
-          <a:ln/>
-        </p:spPr>
-      </p:sp>
-      <p:sp>
-        <p:nvSpPr>
-          <p:cNvPr id="10" name="Text 8"/>
+          <p:cNvPr id="7" name="Text 4"/>
           <p:cNvSpPr/>
           <p:nvPr/>
         </p:nvSpPr>
@@ -4070,7 +3817,7 @@
       </p:sp>
       <p:sp>
         <p:nvSpPr>
-          <p:cNvPr id="11" name="Shape 9"/>
+          <p:cNvPr id="8" name="Shape 5"/>
           <p:cNvSpPr/>
           <p:nvPr/>
         </p:nvSpPr>
@@ -4093,7 +3840,7 @@
       </p:sp>
       <p:sp>
         <p:nvSpPr>
-          <p:cNvPr id="12" name="Text 10"/>
+          <p:cNvPr id="9" name="Text 6"/>
           <p:cNvSpPr/>
           <p:nvPr/>
         </p:nvSpPr>
@@ -4132,7 +3879,7 @@
       </p:sp>
       <p:sp>
         <p:nvSpPr>
-          <p:cNvPr id="13" name="Text 11"/>
+          <p:cNvPr id="10" name="Text 7"/>
           <p:cNvSpPr/>
           <p:nvPr/>
         </p:nvSpPr>
@@ -4299,36 +4046,40 @@
           </a:p>
         </p:txBody>
       </p:sp>
-      <p:sp>
-        <p:nvSpPr>
-          <p:cNvPr id="5" name="Shape 3"/>
-          <p:cNvSpPr/>
-          <p:nvPr/>
-        </p:nvSpPr>
-        <p:spPr>
-          <a:xfrm>
-            <a:off x="566928" y="1627632"/>
-            <a:ext cx="8010144" cy="1005840"/>
-          </a:xfrm>
-          <a:prstGeom prst="rect">
-            <a:avLst/>
-          </a:prstGeom>
-          <a:solidFill>
-            <a:srgbClr val="F5F6FC"/>
-          </a:solidFill>
-          <a:ln/>
-        </p:spPr>
-      </p:sp>
-      <p:sp>
-        <p:nvSpPr>
-          <p:cNvPr id="6" name="Shape 4"/>
-          <p:cNvSpPr/>
-          <p:nvPr/>
-        </p:nvSpPr>
-        <p:spPr>
-          <a:xfrm>
-            <a:off x="566928" y="1627632"/>
-            <a:ext cx="41148" cy="1005840"/>
+      <p:pic>
+        <p:nvPicPr>
+          <p:cNvPr id="5" name="Image 0" descr="/Users/jacobmenge/Desktop/kurs-unterlagen/folien/assets/diagramme/aufgabe-b-geloest.png">    </p:cNvPr>
+          <p:cNvPicPr>
+            <a:picLocks noChangeAspect="1"/>
+          </p:cNvPicPr>
+          <p:nvPr/>
+        </p:nvPicPr>
+        <p:blipFill>
+          <a:blip r:embed="rId1"/>
+          <a:stretch>
+            <a:fillRect/>
+          </a:stretch>
+        </p:blipFill>
+        <p:spPr>
+          <a:xfrm>
+            <a:off x="566928" y="1874520"/>
+            <a:ext cx="8010144" cy="1536192"/>
+          </a:xfrm>
+          <a:prstGeom prst="rect">
+            <a:avLst/>
+          </a:prstGeom>
+        </p:spPr>
+      </p:pic>
+      <p:sp>
+        <p:nvSpPr>
+          <p:cNvPr id="6" name="Shape 3"/>
+          <p:cNvSpPr/>
+          <p:nvPr/>
+        </p:nvSpPr>
+        <p:spPr>
+          <a:xfrm>
+            <a:off x="566928" y="4160520"/>
+            <a:ext cx="32004" cy="256032"/>
           </a:xfrm>
           <a:prstGeom prst="rect">
             <a:avLst/>
@@ -4341,250 +4092,7 @@
       </p:sp>
       <p:sp>
         <p:nvSpPr>
-          <p:cNvPr id="7" name="Text 5"/>
-          <p:cNvSpPr/>
-          <p:nvPr/>
-        </p:nvSpPr>
-        <p:spPr>
-          <a:xfrm>
-            <a:off x="804672" y="1773936"/>
-            <a:ext cx="7607808" cy="292608"/>
-          </a:xfrm>
-          <a:prstGeom prst="rect">
-            <a:avLst/>
-          </a:prstGeom>
-          <a:noFill/>
-          <a:ln/>
-        </p:spPr>
-        <p:txBody>
-          <a:bodyPr wrap="square" lIns="0" tIns="0" rIns="0" bIns="0" rtlCol="0" anchor="t"/>
-          <a:lstStyle/>
-          <a:p>
-            <a:pPr indent="0" marL="0">
-              <a:buNone/>
-            </a:pPr>
-            <a:r>
-              <a:rPr lang="en-US" sz="1400" b="1" dirty="0">
-                <a:solidFill>
-                  <a:srgbClr val="272E52"/>
-                </a:solidFill>
-                <a:latin typeface="Arial" pitchFamily="34" charset="0"/>
-                <a:ea typeface="Arial" pitchFamily="34" charset="-122"/>
-                <a:cs typeface="Arial" pitchFamily="34" charset="-120"/>
-              </a:rPr>
-              <a:t>Eine Abteilung braucht Platz für 40 Geräte.</a:t>
-            </a:r>
-            <a:endParaRPr lang="en-US" sz="1400" dirty="0"/>
-          </a:p>
-        </p:txBody>
-      </p:sp>
-      <p:sp>
-        <p:nvSpPr>
-          <p:cNvPr id="8" name="Text 6"/>
-          <p:cNvSpPr/>
-          <p:nvPr/>
-        </p:nvSpPr>
-        <p:spPr>
-          <a:xfrm>
-            <a:off x="804672" y="2112264"/>
-            <a:ext cx="7607808" cy="402336"/>
-          </a:xfrm>
-          <a:prstGeom prst="rect">
-            <a:avLst/>
-          </a:prstGeom>
-          <a:noFill/>
-          <a:ln/>
-        </p:spPr>
-        <p:txBody>
-          <a:bodyPr wrap="square" lIns="0" tIns="0" rIns="0" bIns="0" rtlCol="0" anchor="t"/>
-          <a:lstStyle/>
-          <a:p>
-            <a:pPr indent="0" marL="0">
-              <a:lnSpc>
-                <a:spcPct val="92000"/>
-              </a:lnSpc>
-              <a:buNone/>
-            </a:pPr>
-            <a:r>
-              <a:rPr lang="en-US" sz="1300" dirty="0">
-                <a:solidFill>
-                  <a:srgbClr val="434A63"/>
-                </a:solidFill>
-                <a:latin typeface="Arial" pitchFamily="34" charset="0"/>
-                <a:ea typeface="Arial" pitchFamily="34" charset="-122"/>
-                <a:cs typeface="Arial" pitchFamily="34" charset="-120"/>
-              </a:rPr>
-              <a:t>Welches Präfix nehmt ihr – und warum nicht eins kleiner?</a:t>
-            </a:r>
-            <a:endParaRPr lang="en-US" sz="1300" dirty="0"/>
-          </a:p>
-        </p:txBody>
-      </p:sp>
-      <p:sp>
-        <p:nvSpPr>
-          <p:cNvPr id="9" name="Text 7"/>
-          <p:cNvSpPr/>
-          <p:nvPr/>
-        </p:nvSpPr>
-        <p:spPr>
-          <a:xfrm>
-            <a:off x="566928" y="2834640"/>
-            <a:ext cx="8010144" cy="1143000"/>
-          </a:xfrm>
-          <a:prstGeom prst="rect">
-            <a:avLst/>
-          </a:prstGeom>
-          <a:noFill/>
-          <a:ln/>
-        </p:spPr>
-        <p:txBody>
-          <a:bodyPr wrap="square" lIns="0" tIns="0" rIns="0" bIns="0" rtlCol="0" anchor="t"/>
-          <a:lstStyle/>
-          <a:p>
-            <a:pPr indent="0" marL="0">
-              <a:lnSpc>
-                <a:spcPct val="92000"/>
-              </a:lnSpc>
-              <a:buNone/>
-            </a:pPr>
-            <a:r>
-              <a:rPr lang="en-US" sz="1250" b="1" dirty="0">
-                <a:solidFill>
-                  <a:srgbClr val="0F7C86"/>
-                </a:solidFill>
-                <a:latin typeface="Arial" pitchFamily="34" charset="0"/>
-                <a:ea typeface="Arial" pitchFamily="34" charset="-122"/>
-                <a:cs typeface="Arial" pitchFamily="34" charset="-120"/>
-              </a:rPr>
-              <a:t>1   </a:t>
-            </a:r>
-            <a:pPr indent="0" marL="0">
-              <a:lnSpc>
-                <a:spcPct val="92000"/>
-              </a:lnSpc>
-              <a:spcAft>
-                <a:spcPts val="900"/>
-              </a:spcAft>
-              <a:buNone/>
-            </a:pPr>
-            <a:r>
-              <a:rPr lang="en-US" sz="1250" dirty="0">
-                <a:solidFill>
-                  <a:srgbClr val="434A63"/>
-                </a:solidFill>
-                <a:latin typeface="Arial" pitchFamily="34" charset="0"/>
-                <a:ea typeface="Arial" pitchFamily="34" charset="-122"/>
-                <a:cs typeface="Arial" pitchFamily="34" charset="-120"/>
-              </a:rPr>
-              <a:t>5 Hostbits: 2⁵ − 2 = 30 nutzbar → reicht nicht für 40</a:t>
-            </a:r>
-            <a:endParaRPr lang="en-US" sz="1250" dirty="0"/>
-          </a:p>
-          <a:p>
-            <a:pPr indent="0" marL="0">
-              <a:lnSpc>
-                <a:spcPct val="92000"/>
-              </a:lnSpc>
-              <a:buNone/>
-            </a:pPr>
-            <a:r>
-              <a:rPr lang="en-US" sz="1250" b="1" dirty="0">
-                <a:solidFill>
-                  <a:srgbClr val="0F7C86"/>
-                </a:solidFill>
-                <a:latin typeface="Arial" pitchFamily="34" charset="0"/>
-                <a:ea typeface="Arial" pitchFamily="34" charset="-122"/>
-                <a:cs typeface="Arial" pitchFamily="34" charset="-120"/>
-              </a:rPr>
-              <a:t>2   </a:t>
-            </a:r>
-            <a:pPr indent="0" marL="0">
-              <a:lnSpc>
-                <a:spcPct val="92000"/>
-              </a:lnSpc>
-              <a:spcAft>
-                <a:spcPts val="900"/>
-              </a:spcAft>
-              <a:buNone/>
-            </a:pPr>
-            <a:r>
-              <a:rPr lang="en-US" sz="1250" dirty="0">
-                <a:solidFill>
-                  <a:srgbClr val="434A63"/>
-                </a:solidFill>
-                <a:latin typeface="Arial" pitchFamily="34" charset="0"/>
-                <a:ea typeface="Arial" pitchFamily="34" charset="-122"/>
-                <a:cs typeface="Arial" pitchFamily="34" charset="-120"/>
-              </a:rPr>
-              <a:t>6 Hostbits: 2⁶ − 2 = 62 nutzbar → passt</a:t>
-            </a:r>
-            <a:endParaRPr lang="en-US" sz="1250" dirty="0"/>
-          </a:p>
-          <a:p>
-            <a:pPr indent="0" marL="0">
-              <a:lnSpc>
-                <a:spcPct val="92000"/>
-              </a:lnSpc>
-              <a:buNone/>
-            </a:pPr>
-            <a:r>
-              <a:rPr lang="en-US" sz="1250" b="1" dirty="0">
-                <a:solidFill>
-                  <a:srgbClr val="0F7C86"/>
-                </a:solidFill>
-                <a:latin typeface="Arial" pitchFamily="34" charset="0"/>
-                <a:ea typeface="Arial" pitchFamily="34" charset="-122"/>
-                <a:cs typeface="Arial" pitchFamily="34" charset="-120"/>
-              </a:rPr>
-              <a:t>3   </a:t>
-            </a:r>
-            <a:pPr indent="0" marL="0">
-              <a:lnSpc>
-                <a:spcPct val="92000"/>
-              </a:lnSpc>
-              <a:spcAft>
-                <a:spcPts val="900"/>
-              </a:spcAft>
-              <a:buNone/>
-            </a:pPr>
-            <a:r>
-              <a:rPr lang="en-US" sz="1250" dirty="0">
-                <a:solidFill>
-                  <a:srgbClr val="434A63"/>
-                </a:solidFill>
-                <a:latin typeface="Arial" pitchFamily="34" charset="0"/>
-                <a:ea typeface="Arial" pitchFamily="34" charset="-122"/>
-                <a:cs typeface="Arial" pitchFamily="34" charset="-120"/>
-              </a:rPr>
-              <a:t>Präfix = 32 − 6 = /26</a:t>
-            </a:r>
-            <a:endParaRPr lang="en-US" sz="1250" dirty="0"/>
-          </a:p>
-        </p:txBody>
-      </p:sp>
-      <p:sp>
-        <p:nvSpPr>
-          <p:cNvPr id="10" name="Shape 8"/>
-          <p:cNvSpPr/>
-          <p:nvPr/>
-        </p:nvSpPr>
-        <p:spPr>
-          <a:xfrm>
-            <a:off x="566928" y="4160520"/>
-            <a:ext cx="32004" cy="256032"/>
-          </a:xfrm>
-          <a:prstGeom prst="rect">
-            <a:avLst/>
-          </a:prstGeom>
-          <a:solidFill>
-            <a:srgbClr val="0F7C86"/>
-          </a:solidFill>
-          <a:ln/>
-        </p:spPr>
-      </p:sp>
-      <p:sp>
-        <p:nvSpPr>
-          <p:cNvPr id="11" name="Text 9"/>
+          <p:cNvPr id="7" name="Text 4"/>
           <p:cNvSpPr/>
           <p:nvPr/>
         </p:nvSpPr>
@@ -4609,13 +4117,13 @@
             <a:r>
               <a:rPr lang="en-US" sz="1200" b="1" dirty="0">
                 <a:solidFill>
-                  <a:srgbClr val="434A63"/>
-                </a:solidFill>
-                <a:latin typeface="Arial" pitchFamily="34" charset="0"/>
-                <a:ea typeface="Arial" pitchFamily="34" charset="-122"/>
-                <a:cs typeface="Arial" pitchFamily="34" charset="-120"/>
-              </a:rPr>
-              <a:t>Immer die kleinste Blockgröße, die noch reicht – plus Blick auf morgen: Wächst die Abteilung?</a:t>
+                  <a:srgbClr val="5C6377"/>
+                </a:solidFill>
+                <a:latin typeface="Arial" pitchFamily="34" charset="0"/>
+                <a:ea typeface="Arial" pitchFamily="34" charset="-122"/>
+                <a:cs typeface="Arial" pitchFamily="34" charset="-120"/>
+              </a:rPr>
+              <a:t>Das Rezept: Hostbits → Blockgröße → Block finden → minus zwei.</a:t>
             </a:r>
             <a:endParaRPr lang="en-US" sz="1200" dirty="0"/>
           </a:p>
@@ -4623,7 +4131,7 @@
       </p:sp>
       <p:sp>
         <p:nvSpPr>
-          <p:cNvPr id="12" name="Shape 10"/>
+          <p:cNvPr id="8" name="Shape 5"/>
           <p:cNvSpPr/>
           <p:nvPr/>
         </p:nvSpPr>
@@ -4646,7 +4154,7 @@
       </p:sp>
       <p:sp>
         <p:nvSpPr>
-          <p:cNvPr id="13" name="Text 11"/>
+          <p:cNvPr id="9" name="Text 6"/>
           <p:cNvSpPr/>
           <p:nvPr/>
         </p:nvSpPr>
@@ -4685,7 +4193,7 @@
       </p:sp>
       <p:sp>
         <p:nvSpPr>
-          <p:cNvPr id="14" name="Text 12"/>
+          <p:cNvPr id="10" name="Text 7"/>
           <p:cNvSpPr/>
           <p:nvPr/>
         </p:nvSpPr>
@@ -4852,36 +4360,40 @@
           </a:p>
         </p:txBody>
       </p:sp>
-      <p:sp>
-        <p:nvSpPr>
-          <p:cNvPr id="5" name="Shape 3"/>
-          <p:cNvSpPr/>
-          <p:nvPr/>
-        </p:nvSpPr>
-        <p:spPr>
-          <a:xfrm>
-            <a:off x="566928" y="1627632"/>
-            <a:ext cx="8010144" cy="1005840"/>
-          </a:xfrm>
-          <a:prstGeom prst="rect">
-            <a:avLst/>
-          </a:prstGeom>
-          <a:solidFill>
-            <a:srgbClr val="F5F6FC"/>
-          </a:solidFill>
-          <a:ln/>
-        </p:spPr>
-      </p:sp>
-      <p:sp>
-        <p:nvSpPr>
-          <p:cNvPr id="6" name="Shape 4"/>
-          <p:cNvSpPr/>
-          <p:nvPr/>
-        </p:nvSpPr>
-        <p:spPr>
-          <a:xfrm>
-            <a:off x="566928" y="1627632"/>
-            <a:ext cx="41148" cy="1005840"/>
+      <p:pic>
+        <p:nvPicPr>
+          <p:cNvPr id="5" name="Image 0" descr="/Users/jacobmenge/Desktop/kurs-unterlagen/folien/assets/diagramme/aufgabe-c-frage.png">    </p:cNvPr>
+          <p:cNvPicPr>
+            <a:picLocks noChangeAspect="1"/>
+          </p:cNvPicPr>
+          <p:nvPr/>
+        </p:nvPicPr>
+        <p:blipFill>
+          <a:blip r:embed="rId1"/>
+          <a:stretch>
+            <a:fillRect/>
+          </a:stretch>
+        </p:blipFill>
+        <p:spPr>
+          <a:xfrm>
+            <a:off x="566928" y="1874520"/>
+            <a:ext cx="8010144" cy="1536192"/>
+          </a:xfrm>
+          <a:prstGeom prst="rect">
+            <a:avLst/>
+          </a:prstGeom>
+        </p:spPr>
+      </p:pic>
+      <p:sp>
+        <p:nvSpPr>
+          <p:cNvPr id="6" name="Shape 3"/>
+          <p:cNvSpPr/>
+          <p:nvPr/>
+        </p:nvSpPr>
+        <p:spPr>
+          <a:xfrm>
+            <a:off x="566928" y="4160520"/>
+            <a:ext cx="32004" cy="256032"/>
           </a:xfrm>
           <a:prstGeom prst="rect">
             <a:avLst/>
@@ -4894,108 +4406,7 @@
       </p:sp>
       <p:sp>
         <p:nvSpPr>
-          <p:cNvPr id="7" name="Text 5"/>
-          <p:cNvSpPr/>
-          <p:nvPr/>
-        </p:nvSpPr>
-        <p:spPr>
-          <a:xfrm>
-            <a:off x="804672" y="1773936"/>
-            <a:ext cx="7607808" cy="292608"/>
-          </a:xfrm>
-          <a:prstGeom prst="rect">
-            <a:avLst/>
-          </a:prstGeom>
-          <a:noFill/>
-          <a:ln/>
-        </p:spPr>
-        <p:txBody>
-          <a:bodyPr wrap="square" lIns="0" tIns="0" rIns="0" bIns="0" rtlCol="0" anchor="t"/>
-          <a:lstStyle/>
-          <a:p>
-            <a:pPr indent="0" marL="0">
-              <a:buNone/>
-            </a:pPr>
-            <a:r>
-              <a:rPr lang="en-US" sz="1400" b="1" dirty="0">
-                <a:solidFill>
-                  <a:srgbClr val="272E52"/>
-                </a:solidFill>
-                <a:latin typeface="Arial" pitchFamily="34" charset="0"/>
-                <a:ea typeface="Arial" pitchFamily="34" charset="-122"/>
-                <a:cs typeface="Arial" pitchFamily="34" charset="-120"/>
-              </a:rPr>
-              <a:t>Die Adresse 172.16.4.130 liegt in einem /23-Netz.</a:t>
-            </a:r>
-            <a:endParaRPr lang="en-US" sz="1400" dirty="0"/>
-          </a:p>
-        </p:txBody>
-      </p:sp>
-      <p:sp>
-        <p:nvSpPr>
-          <p:cNvPr id="8" name="Text 6"/>
-          <p:cNvSpPr/>
-          <p:nvPr/>
-        </p:nvSpPr>
-        <p:spPr>
-          <a:xfrm>
-            <a:off x="804672" y="2112264"/>
-            <a:ext cx="7607808" cy="402336"/>
-          </a:xfrm>
-          <a:prstGeom prst="rect">
-            <a:avLst/>
-          </a:prstGeom>
-          <a:noFill/>
-          <a:ln/>
-        </p:spPr>
-        <p:txBody>
-          <a:bodyPr wrap="square" lIns="0" tIns="0" rIns="0" bIns="0" rtlCol="0" anchor="t"/>
-          <a:lstStyle/>
-          <a:p>
-            <a:pPr indent="0" marL="0">
-              <a:lnSpc>
-                <a:spcPct val="92000"/>
-              </a:lnSpc>
-              <a:buNone/>
-            </a:pPr>
-            <a:r>
-              <a:rPr lang="en-US" sz="1300" dirty="0">
-                <a:solidFill>
-                  <a:srgbClr val="434A63"/>
-                </a:solidFill>
-                <a:latin typeface="Arial" pitchFamily="34" charset="0"/>
-                <a:ea typeface="Arial" pitchFamily="34" charset="-122"/>
-                <a:cs typeface="Arial" pitchFamily="34" charset="-120"/>
-              </a:rPr>
-              <a:t>Netzadresse und Broadcast? Vorsicht, hier reicht das letzte Oktett nicht.</a:t>
-            </a:r>
-            <a:endParaRPr lang="en-US" sz="1300" dirty="0"/>
-          </a:p>
-        </p:txBody>
-      </p:sp>
-      <p:sp>
-        <p:nvSpPr>
-          <p:cNvPr id="9" name="Shape 7"/>
-          <p:cNvSpPr/>
-          <p:nvPr/>
-        </p:nvSpPr>
-        <p:spPr>
-          <a:xfrm>
-            <a:off x="566928" y="4160520"/>
-            <a:ext cx="32004" cy="256032"/>
-          </a:xfrm>
-          <a:prstGeom prst="rect">
-            <a:avLst/>
-          </a:prstGeom>
-          <a:solidFill>
-            <a:srgbClr val="0F7C86"/>
-          </a:solidFill>
-          <a:ln/>
-        </p:spPr>
-      </p:sp>
-      <p:sp>
-        <p:nvSpPr>
-          <p:cNvPr id="10" name="Text 8"/>
+          <p:cNvPr id="7" name="Text 4"/>
           <p:cNvSpPr/>
           <p:nvPr/>
         </p:nvSpPr>
@@ -5034,7 +4445,7 @@
       </p:sp>
       <p:sp>
         <p:nvSpPr>
-          <p:cNvPr id="11" name="Shape 9"/>
+          <p:cNvPr id="8" name="Shape 5"/>
           <p:cNvSpPr/>
           <p:nvPr/>
         </p:nvSpPr>
@@ -5057,7 +4468,7 @@
       </p:sp>
       <p:sp>
         <p:nvSpPr>
-          <p:cNvPr id="12" name="Text 10"/>
+          <p:cNvPr id="9" name="Text 6"/>
           <p:cNvSpPr/>
           <p:nvPr/>
         </p:nvSpPr>
@@ -5096,7 +4507,7 @@
       </p:sp>
       <p:sp>
         <p:nvSpPr>
-          <p:cNvPr id="13" name="Text 11"/>
+          <p:cNvPr id="10" name="Text 7"/>
           <p:cNvSpPr/>
           <p:nvPr/>
         </p:nvSpPr>
@@ -5263,36 +4674,40 @@
           </a:p>
         </p:txBody>
       </p:sp>
-      <p:sp>
-        <p:nvSpPr>
-          <p:cNvPr id="5" name="Shape 3"/>
-          <p:cNvSpPr/>
-          <p:nvPr/>
-        </p:nvSpPr>
-        <p:spPr>
-          <a:xfrm>
-            <a:off x="566928" y="1627632"/>
-            <a:ext cx="8010144" cy="1005840"/>
-          </a:xfrm>
-          <a:prstGeom prst="rect">
-            <a:avLst/>
-          </a:prstGeom>
-          <a:solidFill>
-            <a:srgbClr val="F5F6FC"/>
-          </a:solidFill>
-          <a:ln/>
-        </p:spPr>
-      </p:sp>
-      <p:sp>
-        <p:nvSpPr>
-          <p:cNvPr id="6" name="Shape 4"/>
-          <p:cNvSpPr/>
-          <p:nvPr/>
-        </p:nvSpPr>
-        <p:spPr>
-          <a:xfrm>
-            <a:off x="566928" y="1627632"/>
-            <a:ext cx="41148" cy="1005840"/>
+      <p:pic>
+        <p:nvPicPr>
+          <p:cNvPr id="5" name="Image 0" descr="/Users/jacobmenge/Desktop/kurs-unterlagen/folien/assets/diagramme/aufgabe-c-geloest.png">    </p:cNvPr>
+          <p:cNvPicPr>
+            <a:picLocks noChangeAspect="1"/>
+          </p:cNvPicPr>
+          <p:nvPr/>
+        </p:nvPicPr>
+        <p:blipFill>
+          <a:blip r:embed="rId1"/>
+          <a:stretch>
+            <a:fillRect/>
+          </a:stretch>
+        </p:blipFill>
+        <p:spPr>
+          <a:xfrm>
+            <a:off x="566928" y="1874520"/>
+            <a:ext cx="8010144" cy="1536192"/>
+          </a:xfrm>
+          <a:prstGeom prst="rect">
+            <a:avLst/>
+          </a:prstGeom>
+        </p:spPr>
+      </p:pic>
+      <p:sp>
+        <p:nvSpPr>
+          <p:cNvPr id="6" name="Shape 3"/>
+          <p:cNvSpPr/>
+          <p:nvPr/>
+        </p:nvSpPr>
+        <p:spPr>
+          <a:xfrm>
+            <a:off x="566928" y="4160520"/>
+            <a:ext cx="32004" cy="256032"/>
           </a:xfrm>
           <a:prstGeom prst="rect">
             <a:avLst/>
@@ -5305,250 +4720,7 @@
       </p:sp>
       <p:sp>
         <p:nvSpPr>
-          <p:cNvPr id="7" name="Text 5"/>
-          <p:cNvSpPr/>
-          <p:nvPr/>
-        </p:nvSpPr>
-        <p:spPr>
-          <a:xfrm>
-            <a:off x="804672" y="1773936"/>
-            <a:ext cx="7607808" cy="292608"/>
-          </a:xfrm>
-          <a:prstGeom prst="rect">
-            <a:avLst/>
-          </a:prstGeom>
-          <a:noFill/>
-          <a:ln/>
-        </p:spPr>
-        <p:txBody>
-          <a:bodyPr wrap="square" lIns="0" tIns="0" rIns="0" bIns="0" rtlCol="0" anchor="t"/>
-          <a:lstStyle/>
-          <a:p>
-            <a:pPr indent="0" marL="0">
-              <a:buNone/>
-            </a:pPr>
-            <a:r>
-              <a:rPr lang="en-US" sz="1400" b="1" dirty="0">
-                <a:solidFill>
-                  <a:srgbClr val="272E52"/>
-                </a:solidFill>
-                <a:latin typeface="Arial" pitchFamily="34" charset="0"/>
-                <a:ea typeface="Arial" pitchFamily="34" charset="-122"/>
-                <a:cs typeface="Arial" pitchFamily="34" charset="-120"/>
-              </a:rPr>
-              <a:t>Die Adresse 172.16.4.130 liegt in einem /23-Netz.</a:t>
-            </a:r>
-            <a:endParaRPr lang="en-US" sz="1400" dirty="0"/>
-          </a:p>
-        </p:txBody>
-      </p:sp>
-      <p:sp>
-        <p:nvSpPr>
-          <p:cNvPr id="8" name="Text 6"/>
-          <p:cNvSpPr/>
-          <p:nvPr/>
-        </p:nvSpPr>
-        <p:spPr>
-          <a:xfrm>
-            <a:off x="804672" y="2112264"/>
-            <a:ext cx="7607808" cy="402336"/>
-          </a:xfrm>
-          <a:prstGeom prst="rect">
-            <a:avLst/>
-          </a:prstGeom>
-          <a:noFill/>
-          <a:ln/>
-        </p:spPr>
-        <p:txBody>
-          <a:bodyPr wrap="square" lIns="0" tIns="0" rIns="0" bIns="0" rtlCol="0" anchor="t"/>
-          <a:lstStyle/>
-          <a:p>
-            <a:pPr indent="0" marL="0">
-              <a:lnSpc>
-                <a:spcPct val="92000"/>
-              </a:lnSpc>
-              <a:buNone/>
-            </a:pPr>
-            <a:r>
-              <a:rPr lang="en-US" sz="1300" dirty="0">
-                <a:solidFill>
-                  <a:srgbClr val="434A63"/>
-                </a:solidFill>
-                <a:latin typeface="Arial" pitchFamily="34" charset="0"/>
-                <a:ea typeface="Arial" pitchFamily="34" charset="-122"/>
-                <a:cs typeface="Arial" pitchFamily="34" charset="-120"/>
-              </a:rPr>
-              <a:t>Netzadresse und Broadcast? Vorsicht, hier reicht das letzte Oktett nicht.</a:t>
-            </a:r>
-            <a:endParaRPr lang="en-US" sz="1300" dirty="0"/>
-          </a:p>
-        </p:txBody>
-      </p:sp>
-      <p:sp>
-        <p:nvSpPr>
-          <p:cNvPr id="9" name="Text 7"/>
-          <p:cNvSpPr/>
-          <p:nvPr/>
-        </p:nvSpPr>
-        <p:spPr>
-          <a:xfrm>
-            <a:off x="566928" y="2834640"/>
-            <a:ext cx="8010144" cy="1143000"/>
-          </a:xfrm>
-          <a:prstGeom prst="rect">
-            <a:avLst/>
-          </a:prstGeom>
-          <a:noFill/>
-          <a:ln/>
-        </p:spPr>
-        <p:txBody>
-          <a:bodyPr wrap="square" lIns="0" tIns="0" rIns="0" bIns="0" rtlCol="0" anchor="t"/>
-          <a:lstStyle/>
-          <a:p>
-            <a:pPr indent="0" marL="0">
-              <a:lnSpc>
-                <a:spcPct val="92000"/>
-              </a:lnSpc>
-              <a:buNone/>
-            </a:pPr>
-            <a:r>
-              <a:rPr lang="en-US" sz="1250" b="1" dirty="0">
-                <a:solidFill>
-                  <a:srgbClr val="0F7C86"/>
-                </a:solidFill>
-                <a:latin typeface="Arial" pitchFamily="34" charset="0"/>
-                <a:ea typeface="Arial" pitchFamily="34" charset="-122"/>
-                <a:cs typeface="Arial" pitchFamily="34" charset="-120"/>
-              </a:rPr>
-              <a:t>1   </a:t>
-            </a:r>
-            <a:pPr indent="0" marL="0">
-              <a:lnSpc>
-                <a:spcPct val="92000"/>
-              </a:lnSpc>
-              <a:spcAft>
-                <a:spcPts val="900"/>
-              </a:spcAft>
-              <a:buNone/>
-            </a:pPr>
-            <a:r>
-              <a:rPr lang="en-US" sz="1250" dirty="0">
-                <a:solidFill>
-                  <a:srgbClr val="434A63"/>
-                </a:solidFill>
-                <a:latin typeface="Arial" pitchFamily="34" charset="0"/>
-                <a:ea typeface="Arial" pitchFamily="34" charset="-122"/>
-                <a:cs typeface="Arial" pitchFamily="34" charset="-120"/>
-              </a:rPr>
-              <a:t>9 Hostbits → Blockgröße 512: das dritte Oktett spielt mit, in Zweierschritten</a:t>
-            </a:r>
-            <a:endParaRPr lang="en-US" sz="1250" dirty="0"/>
-          </a:p>
-          <a:p>
-            <a:pPr indent="0" marL="0">
-              <a:lnSpc>
-                <a:spcPct val="92000"/>
-              </a:lnSpc>
-              <a:buNone/>
-            </a:pPr>
-            <a:r>
-              <a:rPr lang="en-US" sz="1250" b="1" dirty="0">
-                <a:solidFill>
-                  <a:srgbClr val="0F7C86"/>
-                </a:solidFill>
-                <a:latin typeface="Arial" pitchFamily="34" charset="0"/>
-                <a:ea typeface="Arial" pitchFamily="34" charset="-122"/>
-                <a:cs typeface="Arial" pitchFamily="34" charset="-120"/>
-              </a:rPr>
-              <a:t>2   </a:t>
-            </a:r>
-            <a:pPr indent="0" marL="0">
-              <a:lnSpc>
-                <a:spcPct val="92000"/>
-              </a:lnSpc>
-              <a:spcAft>
-                <a:spcPts val="900"/>
-              </a:spcAft>
-              <a:buNone/>
-            </a:pPr>
-            <a:r>
-              <a:rPr lang="en-US" sz="1250" dirty="0">
-                <a:solidFill>
-                  <a:srgbClr val="434A63"/>
-                </a:solidFill>
-                <a:latin typeface="Arial" pitchFamily="34" charset="0"/>
-                <a:ea typeface="Arial" pitchFamily="34" charset="-122"/>
-                <a:cs typeface="Arial" pitchFamily="34" charset="-120"/>
-              </a:rPr>
-              <a:t>Netze: 172.16.0.0, 172.16.2.0, 172.16.4.0 … → .4.130 liegt in 172.16.4.0/23</a:t>
-            </a:r>
-            <a:endParaRPr lang="en-US" sz="1250" dirty="0"/>
-          </a:p>
-          <a:p>
-            <a:pPr indent="0" marL="0">
-              <a:lnSpc>
-                <a:spcPct val="92000"/>
-              </a:lnSpc>
-              <a:buNone/>
-            </a:pPr>
-            <a:r>
-              <a:rPr lang="en-US" sz="1250" b="1" dirty="0">
-                <a:solidFill>
-                  <a:srgbClr val="0F7C86"/>
-                </a:solidFill>
-                <a:latin typeface="Arial" pitchFamily="34" charset="0"/>
-                <a:ea typeface="Arial" pitchFamily="34" charset="-122"/>
-                <a:cs typeface="Arial" pitchFamily="34" charset="-120"/>
-              </a:rPr>
-              <a:t>3   </a:t>
-            </a:r>
-            <a:pPr indent="0" marL="0">
-              <a:lnSpc>
-                <a:spcPct val="92000"/>
-              </a:lnSpc>
-              <a:spcAft>
-                <a:spcPts val="900"/>
-              </a:spcAft>
-              <a:buNone/>
-            </a:pPr>
-            <a:r>
-              <a:rPr lang="en-US" sz="1250" dirty="0">
-                <a:solidFill>
-                  <a:srgbClr val="434A63"/>
-                </a:solidFill>
-                <a:latin typeface="Arial" pitchFamily="34" charset="0"/>
-                <a:ea typeface="Arial" pitchFamily="34" charset="-122"/>
-                <a:cs typeface="Arial" pitchFamily="34" charset="-120"/>
-              </a:rPr>
-              <a:t>nutzbar 172.16.4.1 bis 172.16.5.254 · Broadcast 172.16.5.255</a:t>
-            </a:r>
-            <a:endParaRPr lang="en-US" sz="1250" dirty="0"/>
-          </a:p>
-        </p:txBody>
-      </p:sp>
-      <p:sp>
-        <p:nvSpPr>
-          <p:cNvPr id="10" name="Shape 8"/>
-          <p:cNvSpPr/>
-          <p:nvPr/>
-        </p:nvSpPr>
-        <p:spPr>
-          <a:xfrm>
-            <a:off x="566928" y="4160520"/>
-            <a:ext cx="32004" cy="256032"/>
-          </a:xfrm>
-          <a:prstGeom prst="rect">
-            <a:avLst/>
-          </a:prstGeom>
-          <a:solidFill>
-            <a:srgbClr val="0F7C86"/>
-          </a:solidFill>
-          <a:ln/>
-        </p:spPr>
-      </p:sp>
-      <p:sp>
-        <p:nvSpPr>
-          <p:cNvPr id="11" name="Text 9"/>
+          <p:cNvPr id="7" name="Text 4"/>
           <p:cNvSpPr/>
           <p:nvPr/>
         </p:nvSpPr>
@@ -5573,13 +4745,13 @@
             <a:r>
               <a:rPr lang="en-US" sz="1200" b="1" dirty="0">
                 <a:solidFill>
-                  <a:srgbClr val="434A63"/>
-                </a:solidFill>
-                <a:latin typeface="Arial" pitchFamily="34" charset="0"/>
-                <a:ea typeface="Arial" pitchFamily="34" charset="-122"/>
-                <a:cs typeface="Arial" pitchFamily="34" charset="-120"/>
-              </a:rPr>
-              <a:t>Ein Präfix unter /24 heißt: Der Block läuft über mehrere dritte Oktette hinweg.</a:t>
+                  <a:srgbClr val="5C6377"/>
+                </a:solidFill>
+                <a:latin typeface="Arial" pitchFamily="34" charset="0"/>
+                <a:ea typeface="Arial" pitchFamily="34" charset="-122"/>
+                <a:cs typeface="Arial" pitchFamily="34" charset="-120"/>
+              </a:rPr>
+              <a:t>Das Rezept: Hostbits → Blockgröße → Block finden → minus zwei.</a:t>
             </a:r>
             <a:endParaRPr lang="en-US" sz="1200" dirty="0"/>
           </a:p>
@@ -5587,7 +4759,7 @@
       </p:sp>
       <p:sp>
         <p:nvSpPr>
-          <p:cNvPr id="12" name="Shape 10"/>
+          <p:cNvPr id="8" name="Shape 5"/>
           <p:cNvSpPr/>
           <p:nvPr/>
         </p:nvSpPr>
@@ -5610,7 +4782,7 @@
       </p:sp>
       <p:sp>
         <p:nvSpPr>
-          <p:cNvPr id="13" name="Text 11"/>
+          <p:cNvPr id="9" name="Text 6"/>
           <p:cNvSpPr/>
           <p:nvPr/>
         </p:nvSpPr>
@@ -5649,7 +4821,7 @@
       </p:sp>
       <p:sp>
         <p:nvSpPr>
-          <p:cNvPr id="14" name="Text 12"/>
+          <p:cNvPr id="10" name="Text 7"/>
           <p:cNvSpPr/>
           <p:nvPr/>
         </p:nvSpPr>
@@ -15936,36 +15108,40 @@
           </a:p>
         </p:txBody>
       </p:sp>
-      <p:sp>
-        <p:nvSpPr>
-          <p:cNvPr id="5" name="Shape 3"/>
-          <p:cNvSpPr/>
-          <p:nvPr/>
-        </p:nvSpPr>
-        <p:spPr>
-          <a:xfrm>
-            <a:off x="566928" y="1627632"/>
-            <a:ext cx="8010144" cy="1005840"/>
-          </a:xfrm>
-          <a:prstGeom prst="rect">
-            <a:avLst/>
-          </a:prstGeom>
-          <a:solidFill>
-            <a:srgbClr val="F5F6FC"/>
-          </a:solidFill>
-          <a:ln/>
-        </p:spPr>
-      </p:sp>
-      <p:sp>
-        <p:nvSpPr>
-          <p:cNvPr id="6" name="Shape 4"/>
-          <p:cNvSpPr/>
-          <p:nvPr/>
-        </p:nvSpPr>
-        <p:spPr>
-          <a:xfrm>
-            <a:off x="566928" y="1627632"/>
-            <a:ext cx="41148" cy="1005840"/>
+      <p:pic>
+        <p:nvPicPr>
+          <p:cNvPr id="5" name="Image 0" descr="/Users/jacobmenge/Desktop/kurs-unterlagen/folien/assets/diagramme/aufgabe-a-frage.png">    </p:cNvPr>
+          <p:cNvPicPr>
+            <a:picLocks noChangeAspect="1"/>
+          </p:cNvPicPr>
+          <p:nvPr/>
+        </p:nvPicPr>
+        <p:blipFill>
+          <a:blip r:embed="rId1"/>
+          <a:stretch>
+            <a:fillRect/>
+          </a:stretch>
+        </p:blipFill>
+        <p:spPr>
+          <a:xfrm>
+            <a:off x="566928" y="1874520"/>
+            <a:ext cx="8010144" cy="1536192"/>
+          </a:xfrm>
+          <a:prstGeom prst="rect">
+            <a:avLst/>
+          </a:prstGeom>
+        </p:spPr>
+      </p:pic>
+      <p:sp>
+        <p:nvSpPr>
+          <p:cNvPr id="6" name="Shape 3"/>
+          <p:cNvSpPr/>
+          <p:nvPr/>
+        </p:nvSpPr>
+        <p:spPr>
+          <a:xfrm>
+            <a:off x="566928" y="4160520"/>
+            <a:ext cx="32004" cy="256032"/>
           </a:xfrm>
           <a:prstGeom prst="rect">
             <a:avLst/>
@@ -15978,108 +15154,7 @@
       </p:sp>
       <p:sp>
         <p:nvSpPr>
-          <p:cNvPr id="7" name="Text 5"/>
-          <p:cNvSpPr/>
-          <p:nvPr/>
-        </p:nvSpPr>
-        <p:spPr>
-          <a:xfrm>
-            <a:off x="804672" y="1773936"/>
-            <a:ext cx="7607808" cy="292608"/>
-          </a:xfrm>
-          <a:prstGeom prst="rect">
-            <a:avLst/>
-          </a:prstGeom>
-          <a:noFill/>
-          <a:ln/>
-        </p:spPr>
-        <p:txBody>
-          <a:bodyPr wrap="square" lIns="0" tIns="0" rIns="0" bIns="0" rtlCol="0" anchor="t"/>
-          <a:lstStyle/>
-          <a:p>
-            <a:pPr indent="0" marL="0">
-              <a:buNone/>
-            </a:pPr>
-            <a:r>
-              <a:rPr lang="en-US" sz="1400" b="1" dirty="0">
-                <a:solidFill>
-                  <a:srgbClr val="272E52"/>
-                </a:solidFill>
-                <a:latin typeface="Arial" pitchFamily="34" charset="0"/>
-                <a:ea typeface="Arial" pitchFamily="34" charset="-122"/>
-                <a:cs typeface="Arial" pitchFamily="34" charset="-120"/>
-              </a:rPr>
-              <a:t>Die Adresse 192.168.10.77 liegt in einem /26-Netz.</a:t>
-            </a:r>
-            <a:endParaRPr lang="en-US" sz="1400" dirty="0"/>
-          </a:p>
-        </p:txBody>
-      </p:sp>
-      <p:sp>
-        <p:nvSpPr>
-          <p:cNvPr id="8" name="Text 6"/>
-          <p:cNvSpPr/>
-          <p:nvPr/>
-        </p:nvSpPr>
-        <p:spPr>
-          <a:xfrm>
-            <a:off x="804672" y="2112264"/>
-            <a:ext cx="7607808" cy="402336"/>
-          </a:xfrm>
-          <a:prstGeom prst="rect">
-            <a:avLst/>
-          </a:prstGeom>
-          <a:noFill/>
-          <a:ln/>
-        </p:spPr>
-        <p:txBody>
-          <a:bodyPr wrap="square" lIns="0" tIns="0" rIns="0" bIns="0" rtlCol="0" anchor="t"/>
-          <a:lstStyle/>
-          <a:p>
-            <a:pPr indent="0" marL="0">
-              <a:lnSpc>
-                <a:spcPct val="92000"/>
-              </a:lnSpc>
-              <a:buNone/>
-            </a:pPr>
-            <a:r>
-              <a:rPr lang="en-US" sz="1300" dirty="0">
-                <a:solidFill>
-                  <a:srgbClr val="434A63"/>
-                </a:solidFill>
-                <a:latin typeface="Arial" pitchFamily="34" charset="0"/>
-                <a:ea typeface="Arial" pitchFamily="34" charset="-122"/>
-                <a:cs typeface="Arial" pitchFamily="34" charset="-120"/>
-              </a:rPr>
-              <a:t>Netzadresse, erste und letzte nutzbare Adresse, Broadcast?</a:t>
-            </a:r>
-            <a:endParaRPr lang="en-US" sz="1300" dirty="0"/>
-          </a:p>
-        </p:txBody>
-      </p:sp>
-      <p:sp>
-        <p:nvSpPr>
-          <p:cNvPr id="9" name="Shape 7"/>
-          <p:cNvSpPr/>
-          <p:nvPr/>
-        </p:nvSpPr>
-        <p:spPr>
-          <a:xfrm>
-            <a:off x="566928" y="4160520"/>
-            <a:ext cx="32004" cy="256032"/>
-          </a:xfrm>
-          <a:prstGeom prst="rect">
-            <a:avLst/>
-          </a:prstGeom>
-          <a:solidFill>
-            <a:srgbClr val="0F7C86"/>
-          </a:solidFill>
-          <a:ln/>
-        </p:spPr>
-      </p:sp>
-      <p:sp>
-        <p:nvSpPr>
-          <p:cNvPr id="10" name="Text 8"/>
+          <p:cNvPr id="7" name="Text 4"/>
           <p:cNvSpPr/>
           <p:nvPr/>
         </p:nvSpPr>
@@ -16118,7 +15193,7 @@
       </p:sp>
       <p:sp>
         <p:nvSpPr>
-          <p:cNvPr id="11" name="Shape 9"/>
+          <p:cNvPr id="8" name="Shape 5"/>
           <p:cNvSpPr/>
           <p:nvPr/>
         </p:nvSpPr>
@@ -16141,7 +15216,7 @@
       </p:sp>
       <p:sp>
         <p:nvSpPr>
-          <p:cNvPr id="12" name="Text 10"/>
+          <p:cNvPr id="9" name="Text 6"/>
           <p:cNvSpPr/>
           <p:nvPr/>
         </p:nvSpPr>
@@ -16180,7 +15255,7 @@
       </p:sp>
       <p:sp>
         <p:nvSpPr>
-          <p:cNvPr id="13" name="Text 11"/>
+          <p:cNvPr id="10" name="Text 7"/>
           <p:cNvSpPr/>
           <p:nvPr/>
         </p:nvSpPr>

</xml_diff>